<commit_message>
Handle volatile/monitor pricing: list price anchor + monitor/QR for current
- Per-case cost box relabeled to 通常料金 (税込) with a note that 部分/全額
  モニター and current prices are given in-clinic / via QR
- Price page retitled to 通常料金; adds a モニター制度 explainer box (no
  discount figures, per medical-ad caution) plus a latest-price QR
- Keeps the catalog evergreen so campaign changes don't require a reprint

https://claude.ai/code/session_016Wb6e5A68fyGWAtZg4KdQn
</commit_message>
<xml_diff>
--- a/鼻整形_デザインカタログ.pptx
+++ b/鼻整形_デザインカタログ.pptx
@@ -6067,7 +6067,7 @@
                 <a:latin typeface="游ゴシック"/>
                 <a:ea typeface="游ゴシック"/>
               </a:rPr>
-              <a:t>費用（税込・総額）</a:t>
+              <a:t>通常料金（税込）</a:t>
             </a:r>
           </a:p>
         </p:txBody>
@@ -6215,7 +6215,7 @@
                 <a:latin typeface="游ゴシック"/>
                 <a:ea typeface="游ゴシック"/>
               </a:rPr>
-              <a:t>※お支払い例（60回）。金利・回数で変動</a:t>
+              <a:t>※60回の一例。部分／全額モニター・最新料金は院内・QRで</a:t>
             </a:r>
           </a:p>
         </p:txBody>
@@ -8545,7 +8545,7 @@
                 <a:latin typeface="游ゴシック"/>
                 <a:ea typeface="游ゴシック"/>
               </a:rPr>
-              <a:t>費用（税込・総額）</a:t>
+              <a:t>通常料金（税込）</a:t>
             </a:r>
           </a:p>
         </p:txBody>
@@ -8693,7 +8693,7 @@
                 <a:latin typeface="游ゴシック"/>
                 <a:ea typeface="游ゴシック"/>
               </a:rPr>
-              <a:t>※お支払い例（60回）。金利・回数で変動</a:t>
+              <a:t>※60回の一例。部分／全額モニター・最新料金は院内・QRで</a:t>
             </a:r>
           </a:p>
         </p:txBody>
@@ -10613,7 +10613,7 @@
                 <a:latin typeface="游ゴシック"/>
                 <a:ea typeface="游ゴシック"/>
               </a:rPr>
-              <a:t>費用（税込・総額）</a:t>
+              <a:t>通常料金（税込）</a:t>
             </a:r>
           </a:p>
         </p:txBody>
@@ -10761,7 +10761,7 @@
                 <a:latin typeface="游ゴシック"/>
                 <a:ea typeface="游ゴシック"/>
               </a:rPr>
-              <a:t>※お支払い例（60回）。金利・回数で変動</a:t>
+              <a:t>※60回の一例。部分／全額モニター・最新料金は院内・QRで</a:t>
             </a:r>
           </a:p>
         </p:txBody>
@@ -12681,7 +12681,7 @@
                 <a:latin typeface="游ゴシック"/>
                 <a:ea typeface="游ゴシック"/>
               </a:rPr>
-              <a:t>費用（税込・総額）</a:t>
+              <a:t>通常料金（税込）</a:t>
             </a:r>
           </a:p>
         </p:txBody>
@@ -12829,7 +12829,7 @@
                 <a:latin typeface="游ゴシック"/>
                 <a:ea typeface="游ゴシック"/>
               </a:rPr>
-              <a:t>※お支払い例（60回）。金利・回数で変動</a:t>
+              <a:t>※60回の一例。部分／全額モニター・最新料金は院内・QRで</a:t>
             </a:r>
           </a:p>
         </p:txBody>
@@ -16183,7 +16183,7 @@
                 <a:latin typeface="游ゴシック"/>
                 <a:ea typeface="游ゴシック"/>
               </a:rPr>
-              <a:t>費用（税込・総額）</a:t>
+              <a:t>通常料金（税込）</a:t>
             </a:r>
           </a:p>
         </p:txBody>
@@ -16331,7 +16331,7 @@
                 <a:latin typeface="游ゴシック"/>
                 <a:ea typeface="游ゴシック"/>
               </a:rPr>
-              <a:t>※お支払い例（60回）。金利・回数で変動</a:t>
+              <a:t>※60回の一例。部分／全額モニター・最新料金は院内・QRで</a:t>
             </a:r>
           </a:p>
         </p:txBody>
@@ -18661,7 +18661,7 @@
                 <a:latin typeface="游ゴシック"/>
                 <a:ea typeface="游ゴシック"/>
               </a:rPr>
-              <a:t>費用（税込・総額）</a:t>
+              <a:t>通常料金（税込）</a:t>
             </a:r>
           </a:p>
         </p:txBody>
@@ -18809,7 +18809,7 @@
                 <a:latin typeface="游ゴシック"/>
                 <a:ea typeface="游ゴシック"/>
               </a:rPr>
-              <a:t>※お支払い例（60回）。金利・回数で変動</a:t>
+              <a:t>※60回の一例。部分／全額モニター・最新料金は院内・QRで</a:t>
             </a:r>
           </a:p>
         </p:txBody>
@@ -20729,7 +20729,7 @@
                 <a:latin typeface="游ゴシック"/>
                 <a:ea typeface="游ゴシック"/>
               </a:rPr>
-              <a:t>費用（税込・総額）</a:t>
+              <a:t>通常料金（税込）</a:t>
             </a:r>
           </a:p>
         </p:txBody>
@@ -20877,7 +20877,7 @@
                 <a:latin typeface="游ゴシック"/>
                 <a:ea typeface="游ゴシック"/>
               </a:rPr>
-              <a:t>※お支払い例（60回）。金利・回数で変動</a:t>
+              <a:t>※60回の一例。部分／全額モニター・最新料金は院内・QRで</a:t>
             </a:r>
           </a:p>
         </p:txBody>
@@ -22797,7 +22797,7 @@
                 <a:latin typeface="游ゴシック"/>
                 <a:ea typeface="游ゴシック"/>
               </a:rPr>
-              <a:t>費用（税込・総額）</a:t>
+              <a:t>通常料金（税込）</a:t>
             </a:r>
           </a:p>
         </p:txBody>
@@ -22945,7 +22945,7 @@
                 <a:latin typeface="游ゴシック"/>
                 <a:ea typeface="游ゴシック"/>
               </a:rPr>
-              <a:t>※お支払い例（60回）。金利・回数で変動</a:t>
+              <a:t>※60回の一例。部分／全額モニター・最新料金は院内・QRで</a:t>
             </a:r>
           </a:p>
         </p:txBody>
@@ -25972,7 +25972,7 @@
                 <a:latin typeface="游ゴシック"/>
                 <a:ea typeface="游ゴシック"/>
               </a:rPr>
-              <a:t>⑦ 総額＋月々の目安　</a:t>
+              <a:t>⑦ 通常料金＋月々の目安　</a:t>
             </a:r>
           </a:p>
           <a:p>
@@ -25995,7 +25995,7 @@
                 <a:latin typeface="游ゴシック"/>
                 <a:ea typeface="游ゴシック"/>
               </a:rPr>
-              <a:t>税込総額と医療ローン例</a:t>
+              <a:t>税込・通常料金とローン例（モニター価格は別途案内）</a:t>
             </a:r>
           </a:p>
         </p:txBody>
@@ -29261,7 +29261,7 @@
                 <a:latin typeface="游明朝"/>
                 <a:ea typeface="游明朝"/>
               </a:rPr>
-              <a:t>料金・月々のお支払い目安</a:t>
+              <a:t>通常料金・月々のお支払い目安</a:t>
             </a:r>
           </a:p>
         </p:txBody>
@@ -29397,7 +29397,7 @@
                 <a:latin typeface="游ゴシック"/>
                 <a:ea typeface="游ゴシック"/>
               </a:rPr>
-              <a:t>代表的な術式の目安です。組み合わせ・状態により変動します。正式なお見積りはカウンセリングで提示します。</a:t>
+              <a:t>下記は「通常料金（定価）」の目安です。当院は主にモニター制度でのご案内が中心で、実際のご料金はカウンセリングで個別に提示します。</a:t>
             </a:r>
           </a:p>
         </p:txBody>
@@ -29464,7 +29464,7 @@
                           <a:latin typeface="游明朝"/>
                           <a:ea typeface="游明朝"/>
                         </a:rPr>
-                        <a:t>総額（税込）</a:t>
+                        <a:t>通常料金（税込）</a:t>
                       </a:r>
                     </a:p>
                   </a:txBody>
@@ -30103,8 +30103,8 @@
         </p:nvSpPr>
         <p:spPr>
           <a:xfrm>
-            <a:off x="566928" y="6400800"/>
-            <a:ext cx="6428994" cy="1371600"/>
+            <a:off x="566928" y="6263640"/>
+            <a:ext cx="6428994" cy="1600200"/>
           </a:xfrm>
           <a:prstGeom prst="roundRect">
             <a:avLst/>
@@ -30147,8 +30147,8 @@
         </p:nvSpPr>
         <p:spPr>
           <a:xfrm>
-            <a:off x="932688" y="6601968"/>
-            <a:ext cx="5697474" cy="274320"/>
+            <a:off x="932688" y="6464808"/>
+            <a:ext cx="4600194" cy="274320"/>
           </a:xfrm>
           <a:prstGeom prst="rect">
             <a:avLst/>
@@ -30173,14 +30173,14 @@
               </a:spcAft>
             </a:pPr>
             <a:r>
-              <a:rPr sz="1200" b="1">
+              <a:rPr sz="1250" b="1">
                 <a:solidFill>
                   <a:srgbClr val="8C7339"/>
                 </a:solidFill>
                 <a:latin typeface="游明朝"/>
                 <a:ea typeface="游明朝"/>
               </a:rPr>
-              <a:t>お支払いについて</a:t>
+              <a:t>モニター制度について</a:t>
             </a:r>
           </a:p>
         </p:txBody>
@@ -30193,8 +30193,8 @@
         </p:nvSpPr>
         <p:spPr>
           <a:xfrm>
-            <a:off x="932688" y="6949440"/>
-            <a:ext cx="5697474" cy="731520"/>
+            <a:off x="932688" y="6830568"/>
+            <a:ext cx="4508754" cy="960120"/>
           </a:xfrm>
           <a:prstGeom prst="rect">
             <a:avLst/>
@@ -30219,28 +30219,120 @@
               </a:spcAft>
             </a:pPr>
             <a:r>
-              <a:rPr sz="1050" b="0">
+              <a:rPr sz="1000" b="0">
                 <a:solidFill>
                   <a:srgbClr val="3A3326"/>
                 </a:solidFill>
                 <a:latin typeface="游ゴシック"/>
                 <a:ea typeface="游ゴシック"/>
               </a:rPr>
-              <a:t>現金・各種クレジットカード・医療ローン（分割）に対応。月々はローン60回払いの一例です。麻酔・薬・術後の診察を含む「総額」と、ご予算に合わせた月々のプランをカウンセリングでご提案します。</a:t>
-            </a:r>
-          </a:p>
-        </p:txBody>
-      </p:sp>
-      <p:sp>
-        <p:nvSpPr>
-          <p:cNvPr id="12" name="TextBox 11"/>
-          <p:cNvSpPr txBox="1"/>
-          <p:nvPr/>
-        </p:nvSpPr>
-        <p:spPr>
-          <a:xfrm>
-            <a:off x="566928" y="8001000"/>
-            <a:ext cx="6428994" cy="1371600"/>
+              <a:t>当院には【通常料金】のほか【部分モニター】【全額モニター】があります。術前・術後のお写真のご提供にご協力いただける方は、通常料金より割安にご案内できます。適用条件・実際のご料金は、カウンセリングで個別にご案内します（割引額は本資料には掲載していません）。</a:t>
+            </a:r>
+          </a:p>
+        </p:txBody>
+      </p:sp>
+      <p:sp>
+        <p:nvSpPr>
+          <p:cNvPr id="12" name="Rounded Rectangle 11"/>
+          <p:cNvSpPr/>
+          <p:nvPr/>
+        </p:nvSpPr>
+        <p:spPr>
+          <a:xfrm>
+            <a:off x="5670042" y="6583680"/>
+            <a:ext cx="960120" cy="960120"/>
+          </a:xfrm>
+          <a:prstGeom prst="roundRect">
+            <a:avLst/>
+          </a:prstGeom>
+          <a:solidFill>
+            <a:srgbClr val="FFFFFF"/>
+          </a:solidFill>
+          <a:ln w="12700">
+            <a:solidFill>
+              <a:srgbClr val="B0934E"/>
+            </a:solidFill>
+          </a:ln>
+          <a:effectLst/>
+        </p:spPr>
+        <p:style>
+          <a:lnRef idx="1">
+            <a:schemeClr val="accent1"/>
+          </a:lnRef>
+          <a:fillRef idx="3">
+            <a:schemeClr val="accent1"/>
+          </a:fillRef>
+          <a:effectRef idx="2">
+            <a:schemeClr val="accent1"/>
+          </a:effectRef>
+          <a:fontRef idx="minor">
+            <a:schemeClr val="lt1"/>
+          </a:fontRef>
+        </p:style>
+        <p:txBody>
+          <a:bodyPr rtlCol="0" anchor="ctr"/>
+          <a:lstStyle/>
+          <a:p>
+            <a:pPr algn="ctr"/>
+          </a:p>
+        </p:txBody>
+      </p:sp>
+      <p:sp>
+        <p:nvSpPr>
+          <p:cNvPr id="13" name="TextBox 12"/>
+          <p:cNvSpPr txBox="1"/>
+          <p:nvPr/>
+        </p:nvSpPr>
+        <p:spPr>
+          <a:xfrm>
+            <a:off x="5670042" y="6583680"/>
+            <a:ext cx="960120" cy="960120"/>
+          </a:xfrm>
+          <a:prstGeom prst="rect">
+            <a:avLst/>
+          </a:prstGeom>
+          <a:noFill/>
+        </p:spPr>
+        <p:txBody>
+          <a:bodyPr wrap="square" anchor="ctr" lIns="0" rIns="0" tIns="0" bIns="0">
+            <a:spAutoFit/>
+          </a:bodyPr>
+          <a:lstStyle/>
+          <a:p>
+            <a:pPr algn="ctr">
+              <a:lnSpc>
+                <a:spcPct val="112000"/>
+              </a:lnSpc>
+              <a:spcBef>
+                <a:spcPts val="0"/>
+              </a:spcBef>
+              <a:spcAft>
+                <a:spcPts val="200"/>
+              </a:spcAft>
+            </a:pPr>
+            <a:r>
+              <a:rPr sz="1000" b="0">
+                <a:solidFill>
+                  <a:srgbClr val="7A7060"/>
+                </a:solidFill>
+                <a:latin typeface="游ゴシック"/>
+                <a:ea typeface="游ゴシック"/>
+              </a:rPr>
+              <a:t>QR</a:t>
+            </a:r>
+          </a:p>
+        </p:txBody>
+      </p:sp>
+      <p:sp>
+        <p:nvSpPr>
+          <p:cNvPr id="14" name="TextBox 13"/>
+          <p:cNvSpPr txBox="1"/>
+          <p:nvPr/>
+        </p:nvSpPr>
+        <p:spPr>
+          <a:xfrm>
+            <a:off x="5578602" y="7562088"/>
+            <a:ext cx="1143000" cy="228600"/>
           </a:xfrm>
           <a:prstGeom prst="rect">
             <a:avLst/>
@@ -30253,35 +30345,82 @@
           </a:bodyPr>
           <a:lstStyle/>
           <a:p>
+            <a:pPr algn="ctr">
+              <a:lnSpc>
+                <a:spcPct val="112000"/>
+              </a:lnSpc>
+              <a:spcBef>
+                <a:spcPts val="0"/>
+              </a:spcBef>
+              <a:spcAft>
+                <a:spcPts val="200"/>
+              </a:spcAft>
+            </a:pPr>
+            <a:r>
+              <a:rPr sz="800" b="1">
+                <a:solidFill>
+                  <a:srgbClr val="8C7339"/>
+                </a:solidFill>
+                <a:latin typeface="游ゴシック"/>
+                <a:ea typeface="游ゴシック"/>
+              </a:rPr>
+              <a:t>最新料金はこちら</a:t>
+            </a:r>
+          </a:p>
+        </p:txBody>
+      </p:sp>
+      <p:sp>
+        <p:nvSpPr>
+          <p:cNvPr id="15" name="TextBox 14"/>
+          <p:cNvSpPr txBox="1"/>
+          <p:nvPr/>
+        </p:nvSpPr>
+        <p:spPr>
+          <a:xfrm>
+            <a:off x="566928" y="8046720"/>
+            <a:ext cx="6428994" cy="1463040"/>
+          </a:xfrm>
+          <a:prstGeom prst="rect">
+            <a:avLst/>
+          </a:prstGeom>
+          <a:noFill/>
+        </p:spPr>
+        <p:txBody>
+          <a:bodyPr wrap="square" anchor="t" lIns="0" rIns="0" tIns="0" bIns="0">
+            <a:spAutoFit/>
+          </a:bodyPr>
+          <a:lstStyle/>
+          <a:p>
             <a:pPr algn="l">
               <a:lnSpc>
-                <a:spcPct val="170000"/>
-              </a:lnSpc>
-              <a:spcBef>
-                <a:spcPts val="0"/>
-              </a:spcBef>
-              <a:spcAft>
-                <a:spcPts val="200"/>
-              </a:spcAft>
-            </a:pPr>
-            <a:r>
-              <a:rPr sz="950" b="0">
+                <a:spcPct val="160000"/>
+              </a:lnSpc>
+              <a:spcBef>
+                <a:spcPts val="0"/>
+              </a:spcBef>
+              <a:spcAft>
+                <a:spcPts val="200"/>
+              </a:spcAft>
+            </a:pPr>
+            <a:r>
+              <a:rPr sz="900" b="0">
                 <a:solidFill>
                   <a:srgbClr val="7A7060"/>
                 </a:solidFill>
                 <a:latin typeface="游ゴシック"/>
                 <a:ea typeface="游ゴシック"/>
               </a:rPr>
-              <a:t>※ 上記は手術料金の目安です。鼻整形は自由診療（保険適用外）です。
-※ 月々の金額は金利・支払回数により変動します。実際のお支払い例は店頭でご確認ください。
-※ 5周年キャンペーン等の最新情報は @zetith_hane / 院内にてご案内します。</a:t>
-            </a:r>
-          </a:p>
-        </p:txBody>
-      </p:sp>
-      <p:sp>
-        <p:nvSpPr>
-          <p:cNvPr id="13" name="TextBox 12"/>
+              <a:t>※ 上記は「通常料金」の目安です。鼻整形は自由診療（保険適用外）です。
+※ 月々は通常料金・60回払いの一例で、金利・支払回数により変動します（現金・各種クレジット・医療ローン対応）。
+※ モニター価格の具体的な割引額は、医療広告の観点から本資料には掲載していません。院内・カウンセリングでご案内します。
+※ 最新の料金・キャンペーンは @zetith_hane／院内・上記QRにてご確認ください。</a:t>
+            </a:r>
+          </a:p>
+        </p:txBody>
+      </p:sp>
+      <p:sp>
+        <p:nvSpPr>
+          <p:cNvPr id="16" name="TextBox 15"/>
           <p:cNvSpPr txBox="1"/>
           <p:nvPr/>
         </p:nvSpPr>
@@ -30320,14 +30459,14 @@
                 <a:latin typeface="游ゴシック"/>
                 <a:ea typeface="游ゴシック"/>
               </a:rPr>
-              <a:t>鼻整形 デザインカタログ｜料金・月々のお支払い目安</a:t>
-            </a:r>
-          </a:p>
-        </p:txBody>
-      </p:sp>
-      <p:sp>
-        <p:nvSpPr>
-          <p:cNvPr id="14" name="TextBox 13"/>
+              <a:t>鼻整形 デザインカタログ｜通常料金・月々のお支払い目安</a:t>
+            </a:r>
+          </a:p>
+        </p:txBody>
+      </p:sp>
+      <p:sp>
+        <p:nvSpPr>
+          <p:cNvPr id="17" name="TextBox 16"/>
           <p:cNvSpPr txBox="1"/>
           <p:nvPr/>
         </p:nvSpPr>
@@ -36696,7 +36835,7 @@
                 <a:latin typeface="游ゴシック"/>
                 <a:ea typeface="游ゴシック"/>
               </a:rPr>
-              <a:t>費用（税込・総額）</a:t>
+              <a:t>通常料金（税込）</a:t>
             </a:r>
           </a:p>
         </p:txBody>
@@ -36844,7 +36983,7 @@
                 <a:latin typeface="游ゴシック"/>
                 <a:ea typeface="游ゴシック"/>
               </a:rPr>
-              <a:t>※お支払い例（60回）。金利・回数で変動</a:t>
+              <a:t>※60回の一例。部分／全額モニター・最新料金は院内・QRで</a:t>
             </a:r>
           </a:p>
         </p:txBody>
@@ -39174,7 +39313,7 @@
                 <a:latin typeface="游ゴシック"/>
                 <a:ea typeface="游ゴシック"/>
               </a:rPr>
-              <a:t>費用（税込・総額）</a:t>
+              <a:t>通常料金（税込）</a:t>
             </a:r>
           </a:p>
         </p:txBody>
@@ -39322,7 +39461,7 @@
                 <a:latin typeface="游ゴシック"/>
                 <a:ea typeface="游ゴシック"/>
               </a:rPr>
-              <a:t>※お支払い例（60回）。金利・回数で変動</a:t>
+              <a:t>※60回の一例。部分／全額モニター・最新料金は院内・QRで</a:t>
             </a:r>
           </a:p>
         </p:txBody>
@@ -41652,7 +41791,7 @@
                 <a:latin typeface="游ゴシック"/>
                 <a:ea typeface="游ゴシック"/>
               </a:rPr>
-              <a:t>費用（税込・総額）</a:t>
+              <a:t>通常料金（税込）</a:t>
             </a:r>
           </a:p>
         </p:txBody>
@@ -41800,7 +41939,7 @@
                 <a:latin typeface="游ゴシック"/>
                 <a:ea typeface="游ゴシック"/>
               </a:rPr>
-              <a:t>※お支払い例（60回）。金利・回数で変動</a:t>
+              <a:t>※60回の一例。部分／全額モニター・最新料金は院内・QRで</a:t>
             </a:r>
           </a:p>
         </p:txBody>
@@ -43720,7 +43859,7 @@
                 <a:latin typeface="游ゴシック"/>
                 <a:ea typeface="游ゴシック"/>
               </a:rPr>
-              <a:t>費用（税込・総額）</a:t>
+              <a:t>通常料金（税込）</a:t>
             </a:r>
           </a:p>
         </p:txBody>
@@ -43868,7 +44007,7 @@
                 <a:latin typeface="游ゴシック"/>
                 <a:ea typeface="游ゴシック"/>
               </a:rPr>
-              <a:t>※お支払い例（60回）。金利・回数で変動</a:t>
+              <a:t>※60回の一例。部分／全額モニター・最新料金は院内・QRで</a:t>
             </a:r>
           </a:p>
         </p:txBody>

</xml_diff>

<commit_message>
Remove price-page QR (keep reservation QR); tidy notes
- Drop the '最新料金' QR on the price page; monitor-system box now full width
- Keep the reservation 'WEB/LINE' QR as-is
- Update notes to point to 院内・カウンセリング instead of QR

https://claude.ai/code/session_016Wb6e5A68fyGWAtZg4KdQn
</commit_message>
<xml_diff>
--- a/鼻整形_デザインカタログ.pptx
+++ b/鼻整形_デザインカタログ.pptx
@@ -6154,7 +6154,7 @@
                 <a:latin typeface="游ゴシック"/>
                 <a:ea typeface="游ゴシック"/>
               </a:rPr>
-              <a:t>※60回の一例。部分／全額モニター・最新料金は院内・QRで</a:t>
+              <a:t>※60回の一例。部分／全額モニター・最新料金は院内・カウンセリングで</a:t>
             </a:r>
           </a:p>
         </p:txBody>
@@ -7652,7 +7652,7 @@
                 <a:latin typeface="游ゴシック"/>
                 <a:ea typeface="游ゴシック"/>
               </a:rPr>
-              <a:t>※60回の一例。部分／全額モニター・最新料金は院内・QRで</a:t>
+              <a:t>※60回の一例。部分／全額モニター・最新料金は院内・カウンセリングで</a:t>
             </a:r>
           </a:p>
         </p:txBody>
@@ -9150,7 +9150,7 @@
                 <a:latin typeface="游ゴシック"/>
                 <a:ea typeface="游ゴシック"/>
               </a:rPr>
-              <a:t>※60回の一例。部分／全額モニター・最新料金は院内・QRで</a:t>
+              <a:t>※60回の一例。部分／全額モニター・最新料金は院内・カウンセリングで</a:t>
             </a:r>
           </a:p>
         </p:txBody>
@@ -10648,7 +10648,7 @@
                 <a:latin typeface="游ゴシック"/>
                 <a:ea typeface="游ゴシック"/>
               </a:rPr>
-              <a:t>※60回の一例。部分／全額モニター・最新料金は院内・QRで</a:t>
+              <a:t>※60回の一例。部分／全額モニター・最新料金は院内・カウンセリングで</a:t>
             </a:r>
           </a:p>
         </p:txBody>
@@ -13032,7 +13032,7 @@
                 <a:latin typeface="游ゴシック"/>
                 <a:ea typeface="游ゴシック"/>
               </a:rPr>
-              <a:t>※60回の一例。部分／全額モニター・最新料金は院内・QRで</a:t>
+              <a:t>※60回の一例。部分／全額モニター・最新料金は院内・カウンセリングで</a:t>
             </a:r>
           </a:p>
         </p:txBody>
@@ -14530,7 +14530,7 @@
                 <a:latin typeface="游ゴシック"/>
                 <a:ea typeface="游ゴシック"/>
               </a:rPr>
-              <a:t>※60回の一例。部分／全額モニター・最新料金は院内・QRで</a:t>
+              <a:t>※60回の一例。部分／全額モニター・最新料金は院内・カウンセリングで</a:t>
             </a:r>
           </a:p>
         </p:txBody>
@@ -16028,7 +16028,7 @@
                 <a:latin typeface="游ゴシック"/>
                 <a:ea typeface="游ゴシック"/>
               </a:rPr>
-              <a:t>※60回の一例。部分／全額モニター・最新料金は院内・QRで</a:t>
+              <a:t>※60回の一例。部分／全額モニター・最新料金は院内・カウンセリングで</a:t>
             </a:r>
           </a:p>
         </p:txBody>
@@ -19987,7 +19987,7 @@
                 <a:latin typeface="游ゴシック"/>
                 <a:ea typeface="游ゴシック"/>
               </a:rPr>
-              <a:t>※60回の一例。部分／全額モニター・最新料金は院内・QRで</a:t>
+              <a:t>※60回の一例。部分／全額モニター・最新料金は院内・カウンセリングで</a:t>
             </a:r>
           </a:p>
         </p:txBody>
@@ -21485,7 +21485,7 @@
                 <a:latin typeface="游ゴシック"/>
                 <a:ea typeface="游ゴシック"/>
               </a:rPr>
-              <a:t>※60回の一例。部分／全額モニター・最新料金は院内・QRで</a:t>
+              <a:t>※60回の一例。部分／全額モニター・最新料金は院内・カウンセリングで</a:t>
             </a:r>
           </a:p>
         </p:txBody>
@@ -22983,7 +22983,7 @@
                 <a:latin typeface="游ゴシック"/>
                 <a:ea typeface="游ゴシック"/>
               </a:rPr>
-              <a:t>※60回の一例。部分／全額モニター・最新料金は院内・QRで</a:t>
+              <a:t>※60回の一例。部分／全額モニター・最新料金は院内・カウンセリングで</a:t>
             </a:r>
           </a:p>
         </p:txBody>
@@ -25229,7 +25229,7 @@
                 <a:latin typeface="游ゴシック"/>
                 <a:ea typeface="游ゴシック"/>
               </a:rPr>
-              <a:t>※60回の一例。部分／全額モニター・最新料金は院内・QRで</a:t>
+              <a:t>※60回の一例。部分／全額モニター・最新料金は院内・カウンセリングで</a:t>
             </a:r>
           </a:p>
         </p:txBody>
@@ -26671,7 +26671,7 @@
                 <a:latin typeface="游ゴシック"/>
                 <a:ea typeface="游ゴシック"/>
               </a:rPr>
-              <a:t>※60回の一例。部分／全額モニター・最新料金は院内・QRで</a:t>
+              <a:t>※60回の一例。部分／全額モニター・最新料金は院内・カウンセリングで</a:t>
             </a:r>
           </a:p>
         </p:txBody>
@@ -32541,7 +32541,7 @@
         <p:spPr>
           <a:xfrm>
             <a:off x="932688" y="6601968"/>
-            <a:ext cx="4600194" cy="274320"/>
+            <a:ext cx="5697474" cy="274320"/>
           </a:xfrm>
           <a:prstGeom prst="rect">
             <a:avLst/>
@@ -32587,7 +32587,7 @@
         <p:spPr>
           <a:xfrm>
             <a:off x="932688" y="6967728"/>
-            <a:ext cx="4508754" cy="914400"/>
+            <a:ext cx="5697474" cy="914400"/>
           </a:xfrm>
           <a:prstGeom prst="rect">
             <a:avLst/>
@@ -32602,17 +32602,17 @@
           <a:p>
             <a:pPr algn="l">
               <a:lnSpc>
-                <a:spcPct val="150000"/>
-              </a:lnSpc>
-              <a:spcBef>
-                <a:spcPts val="0"/>
-              </a:spcBef>
-              <a:spcAft>
-                <a:spcPts val="200"/>
-              </a:spcAft>
-            </a:pPr>
-            <a:r>
-              <a:rPr sz="1000" b="0">
+                <a:spcPct val="155000"/>
+              </a:lnSpc>
+              <a:spcBef>
+                <a:spcPts val="0"/>
+              </a:spcBef>
+              <a:spcAft>
+                <a:spcPts val="200"/>
+              </a:spcAft>
+            </a:pPr>
+            <a:r>
+              <a:rPr sz="1050" b="0">
                 <a:solidFill>
                   <a:srgbClr val="3A3326"/>
                 </a:solidFill>
@@ -32626,145 +32626,7 @@
       </p:sp>
       <p:sp>
         <p:nvSpPr>
-          <p:cNvPr id="12" name="Rounded Rectangle 11"/>
-          <p:cNvSpPr/>
-          <p:nvPr/>
-        </p:nvSpPr>
-        <p:spPr>
-          <a:xfrm>
-            <a:off x="5670042" y="6720840"/>
-            <a:ext cx="960120" cy="960120"/>
-          </a:xfrm>
-          <a:prstGeom prst="roundRect">
-            <a:avLst/>
-          </a:prstGeom>
-          <a:solidFill>
-            <a:srgbClr val="FFFFFF"/>
-          </a:solidFill>
-          <a:ln w="12700">
-            <a:solidFill>
-              <a:srgbClr val="B0934E"/>
-            </a:solidFill>
-          </a:ln>
-          <a:effectLst/>
-        </p:spPr>
-        <p:style>
-          <a:lnRef idx="1">
-            <a:schemeClr val="accent1"/>
-          </a:lnRef>
-          <a:fillRef idx="3">
-            <a:schemeClr val="accent1"/>
-          </a:fillRef>
-          <a:effectRef idx="2">
-            <a:schemeClr val="accent1"/>
-          </a:effectRef>
-          <a:fontRef idx="minor">
-            <a:schemeClr val="lt1"/>
-          </a:fontRef>
-        </p:style>
-        <p:txBody>
-          <a:bodyPr rtlCol="0" anchor="ctr"/>
-          <a:lstStyle/>
-          <a:p>
-            <a:pPr algn="ctr"/>
-          </a:p>
-        </p:txBody>
-      </p:sp>
-      <p:sp>
-        <p:nvSpPr>
-          <p:cNvPr id="13" name="TextBox 12"/>
-          <p:cNvSpPr txBox="1"/>
-          <p:nvPr/>
-        </p:nvSpPr>
-        <p:spPr>
-          <a:xfrm>
-            <a:off x="5670042" y="6720840"/>
-            <a:ext cx="960120" cy="960120"/>
-          </a:xfrm>
-          <a:prstGeom prst="rect">
-            <a:avLst/>
-          </a:prstGeom>
-          <a:noFill/>
-        </p:spPr>
-        <p:txBody>
-          <a:bodyPr wrap="square" anchor="ctr" lIns="0" rIns="0" tIns="0" bIns="0">
-            <a:spAutoFit/>
-          </a:bodyPr>
-          <a:lstStyle/>
-          <a:p>
-            <a:pPr algn="ctr">
-              <a:lnSpc>
-                <a:spcPct val="112000"/>
-              </a:lnSpc>
-              <a:spcBef>
-                <a:spcPts val="0"/>
-              </a:spcBef>
-              <a:spcAft>
-                <a:spcPts val="200"/>
-              </a:spcAft>
-            </a:pPr>
-            <a:r>
-              <a:rPr sz="1000" b="0">
-                <a:solidFill>
-                  <a:srgbClr val="7A7060"/>
-                </a:solidFill>
-                <a:latin typeface="游ゴシック"/>
-                <a:ea typeface="游ゴシック"/>
-              </a:rPr>
-              <a:t>QR</a:t>
-            </a:r>
-          </a:p>
-        </p:txBody>
-      </p:sp>
-      <p:sp>
-        <p:nvSpPr>
-          <p:cNvPr id="14" name="TextBox 13"/>
-          <p:cNvSpPr txBox="1"/>
-          <p:nvPr/>
-        </p:nvSpPr>
-        <p:spPr>
-          <a:xfrm>
-            <a:off x="5578602" y="7699248"/>
-            <a:ext cx="1143000" cy="228600"/>
-          </a:xfrm>
-          <a:prstGeom prst="rect">
-            <a:avLst/>
-          </a:prstGeom>
-          <a:noFill/>
-        </p:spPr>
-        <p:txBody>
-          <a:bodyPr wrap="square" anchor="t" lIns="0" rIns="0" tIns="0" bIns="0">
-            <a:spAutoFit/>
-          </a:bodyPr>
-          <a:lstStyle/>
-          <a:p>
-            <a:pPr algn="ctr">
-              <a:lnSpc>
-                <a:spcPct val="112000"/>
-              </a:lnSpc>
-              <a:spcBef>
-                <a:spcPts val="0"/>
-              </a:spcBef>
-              <a:spcAft>
-                <a:spcPts val="200"/>
-              </a:spcAft>
-            </a:pPr>
-            <a:r>
-              <a:rPr sz="800" b="1">
-                <a:solidFill>
-                  <a:srgbClr val="8C7339"/>
-                </a:solidFill>
-                <a:latin typeface="游ゴシック"/>
-                <a:ea typeface="游ゴシック"/>
-              </a:rPr>
-              <a:t>最新料金はこちら</a:t>
-            </a:r>
-          </a:p>
-        </p:txBody>
-      </p:sp>
-      <p:sp>
-        <p:nvSpPr>
-          <p:cNvPr id="15" name="TextBox 14"/>
+          <p:cNvPr id="12" name="TextBox 11"/>
           <p:cNvSpPr txBox="1"/>
           <p:nvPr/>
         </p:nvSpPr>
@@ -32806,14 +32668,14 @@
               <a:t>※ 上記は「通常料金」の目安です。鼻整形は自由診療（保険適用外）です。
 ※ 月々は通常料金・60回払いの一例で、金利・支払回数により変動します（現金・各種クレジット・医療ローン対応）。
 ※ モニター価格の具体的な割引額は、医療広告の観点から本資料には掲載していません。院内・カウンセリングでご案内します。
-※ 最新の料金・キャンペーンは @zetith_hane／院内・上記QRにてご確認ください。</a:t>
-            </a:r>
-          </a:p>
-        </p:txBody>
-      </p:sp>
-      <p:sp>
-        <p:nvSpPr>
-          <p:cNvPr id="16" name="TextBox 15"/>
+※ 最新の料金・キャンペーンは @zetith_hane／院内・カウンセリングにてご確認ください。</a:t>
+            </a:r>
+          </a:p>
+        </p:txBody>
+      </p:sp>
+      <p:sp>
+        <p:nvSpPr>
+          <p:cNvPr id="13" name="TextBox 12"/>
           <p:cNvSpPr txBox="1"/>
           <p:nvPr/>
         </p:nvSpPr>
@@ -32859,7 +32721,7 @@
       </p:sp>
       <p:sp>
         <p:nvSpPr>
-          <p:cNvPr id="17" name="TextBox 16"/>
+          <p:cNvPr id="14" name="TextBox 13"/>
           <p:cNvSpPr txBox="1"/>
           <p:nvPr/>
         </p:nvSpPr>
@@ -40404,7 +40266,7 @@
                 <a:latin typeface="游ゴシック"/>
                 <a:ea typeface="游ゴシック"/>
               </a:rPr>
-              <a:t>※60回の一例。部分／全額モニター・最新料金は院内・QRで</a:t>
+              <a:t>※60回の一例。部分／全額モニター・最新料金は院内・カウンセリングで</a:t>
             </a:r>
           </a:p>
         </p:txBody>
@@ -41902,7 +41764,7 @@
                 <a:latin typeface="游ゴシック"/>
                 <a:ea typeface="游ゴシック"/>
               </a:rPr>
-              <a:t>※60回の一例。部分／全額モニター・最新料金は院内・QRで</a:t>
+              <a:t>※60回の一例。部分／全額モニター・最新料金は院内・カウンセリングで</a:t>
             </a:r>
           </a:p>
         </p:txBody>
@@ -43400,7 +43262,7 @@
                 <a:latin typeface="游ゴシック"/>
                 <a:ea typeface="游ゴシック"/>
               </a:rPr>
-              <a:t>※60回の一例。部分／全額モニター・最新料金は院内・QRで</a:t>
+              <a:t>※60回の一例。部分／全額モニター・最新料金は院内・カウンセリングで</a:t>
             </a:r>
           </a:p>
         </p:txBody>
@@ -44898,7 +44760,7 @@
                 <a:latin typeface="游ゴシック"/>
                 <a:ea typeface="游ゴシック"/>
               </a:rPr>
-              <a:t>※60回の一例。部分／全額モニター・最新料金は院内・QRで</a:t>
+              <a:t>※60回の一例。部分／全額モニター・最新料金は院内・カウンセリングで</a:t>
             </a:r>
           </a:p>
         </p:txBody>

</xml_diff>

<commit_message>
Make case photo frames exact half-square (1:2) halves of a square
- Each Before/After placeholder is now 1.70 x 3.40in (1:2), the two touching to
  form a 3.4in square, centered

https://claude.ai/code/session_016Wb6e5A68fyGWAtZg4KdQn
</commit_message>
<xml_diff>
--- a/鼻整形_デザインカタログ.pptx
+++ b/鼻整形_デザインカタログ.pptx
@@ -757,12 +757,12 @@
         </p:nvSpPr>
         <p:spPr>
           <a:xfrm>
-            <a:off x="1038225" y="2240280"/>
-            <a:ext cx="2606040" cy="3200400"/>
+            <a:off x="2226945" y="2240280"/>
+            <a:ext cx="1554480" cy="3108960"/>
           </a:xfrm>
           <a:prstGeom prst="roundRect">
             <a:avLst>
-              <a:gd name="adj" fmla="val 5000"/>
+              <a:gd name="adj" fmla="val 4000"/>
             </a:avLst>
           </a:prstGeom>
           <a:solidFill>
@@ -787,12 +787,12 @@
         </p:nvSpPr>
         <p:spPr>
           <a:xfrm>
-            <a:off x="3918585" y="2240280"/>
-            <a:ext cx="2606040" cy="3200400"/>
+            <a:off x="3781425" y="2240280"/>
+            <a:ext cx="1554480" cy="3108960"/>
           </a:xfrm>
           <a:prstGeom prst="roundRect">
             <a:avLst>
-              <a:gd name="adj" fmla="val 5000"/>
+              <a:gd name="adj" fmla="val 4000"/>
             </a:avLst>
           </a:prstGeom>
           <a:solidFill>
@@ -5389,8 +5389,8 @@
         </p:nvSpPr>
         <p:spPr>
           <a:xfrm>
-            <a:off x="1038225" y="1874519"/>
-            <a:ext cx="2606040" cy="274320"/>
+            <a:off x="2226945" y="1874519"/>
+            <a:ext cx="1554480" cy="274320"/>
           </a:xfrm>
           <a:prstGeom prst="rect">
             <a:avLst/>
@@ -5435,8 +5435,8 @@
         </p:nvSpPr>
         <p:spPr>
           <a:xfrm>
-            <a:off x="3918585" y="1874519"/>
-            <a:ext cx="2606040" cy="274320"/>
+            <a:off x="3781425" y="1874519"/>
+            <a:ext cx="1554480" cy="274320"/>
           </a:xfrm>
           <a:prstGeom prst="rect">
             <a:avLst/>
@@ -5481,8 +5481,8 @@
         </p:nvSpPr>
         <p:spPr>
           <a:xfrm>
-            <a:off x="1038225" y="1874519"/>
-            <a:ext cx="5486400" cy="274320"/>
+            <a:off x="2226945" y="1874519"/>
+            <a:ext cx="3108960" cy="274320"/>
           </a:xfrm>
           <a:prstGeom prst="rect">
             <a:avLst/>
@@ -6991,8 +6991,8 @@
         </p:nvSpPr>
         <p:spPr>
           <a:xfrm>
-            <a:off x="1038225" y="1874519"/>
-            <a:ext cx="2606040" cy="274320"/>
+            <a:off x="2226945" y="1874519"/>
+            <a:ext cx="1554480" cy="274320"/>
           </a:xfrm>
           <a:prstGeom prst="rect">
             <a:avLst/>
@@ -7037,8 +7037,8 @@
         </p:nvSpPr>
         <p:spPr>
           <a:xfrm>
-            <a:off x="3918585" y="1874519"/>
-            <a:ext cx="2606040" cy="274320"/>
+            <a:off x="3781425" y="1874519"/>
+            <a:ext cx="1554480" cy="274320"/>
           </a:xfrm>
           <a:prstGeom prst="rect">
             <a:avLst/>
@@ -7083,8 +7083,8 @@
         </p:nvSpPr>
         <p:spPr>
           <a:xfrm>
-            <a:off x="1038225" y="1874519"/>
-            <a:ext cx="5486400" cy="274320"/>
+            <a:off x="2226945" y="1874519"/>
+            <a:ext cx="3108960" cy="274320"/>
           </a:xfrm>
           <a:prstGeom prst="rect">
             <a:avLst/>
@@ -8593,8 +8593,8 @@
         </p:nvSpPr>
         <p:spPr>
           <a:xfrm>
-            <a:off x="1038225" y="1874519"/>
-            <a:ext cx="2606040" cy="274320"/>
+            <a:off x="2226945" y="1874519"/>
+            <a:ext cx="1554480" cy="274320"/>
           </a:xfrm>
           <a:prstGeom prst="rect">
             <a:avLst/>
@@ -8639,8 +8639,8 @@
         </p:nvSpPr>
         <p:spPr>
           <a:xfrm>
-            <a:off x="3918585" y="1874519"/>
-            <a:ext cx="2606040" cy="274320"/>
+            <a:off x="3781425" y="1874519"/>
+            <a:ext cx="1554480" cy="274320"/>
           </a:xfrm>
           <a:prstGeom prst="rect">
             <a:avLst/>
@@ -8685,8 +8685,8 @@
         </p:nvSpPr>
         <p:spPr>
           <a:xfrm>
-            <a:off x="1038225" y="1874519"/>
-            <a:ext cx="5486400" cy="274320"/>
+            <a:off x="2226945" y="1874519"/>
+            <a:ext cx="3108960" cy="274320"/>
           </a:xfrm>
           <a:prstGeom prst="rect">
             <a:avLst/>
@@ -10195,8 +10195,8 @@
         </p:nvSpPr>
         <p:spPr>
           <a:xfrm>
-            <a:off x="1038225" y="1874519"/>
-            <a:ext cx="2606040" cy="274320"/>
+            <a:off x="2226945" y="1874519"/>
+            <a:ext cx="1554480" cy="274320"/>
           </a:xfrm>
           <a:prstGeom prst="rect">
             <a:avLst/>
@@ -10241,8 +10241,8 @@
         </p:nvSpPr>
         <p:spPr>
           <a:xfrm>
-            <a:off x="3918585" y="1874519"/>
-            <a:ext cx="2606040" cy="274320"/>
+            <a:off x="3781425" y="1874519"/>
+            <a:ext cx="1554480" cy="274320"/>
           </a:xfrm>
           <a:prstGeom prst="rect">
             <a:avLst/>
@@ -10287,8 +10287,8 @@
         </p:nvSpPr>
         <p:spPr>
           <a:xfrm>
-            <a:off x="1038225" y="1874519"/>
-            <a:ext cx="5486400" cy="274320"/>
+            <a:off x="2226945" y="1874519"/>
+            <a:ext cx="3108960" cy="274320"/>
           </a:xfrm>
           <a:prstGeom prst="rect">
             <a:avLst/>
@@ -12683,8 +12683,8 @@
         </p:nvSpPr>
         <p:spPr>
           <a:xfrm>
-            <a:off x="1038225" y="1874519"/>
-            <a:ext cx="2606040" cy="274320"/>
+            <a:off x="2226945" y="1874519"/>
+            <a:ext cx="1554480" cy="274320"/>
           </a:xfrm>
           <a:prstGeom prst="rect">
             <a:avLst/>
@@ -12729,8 +12729,8 @@
         </p:nvSpPr>
         <p:spPr>
           <a:xfrm>
-            <a:off x="3918585" y="1874519"/>
-            <a:ext cx="2606040" cy="274320"/>
+            <a:off x="3781425" y="1874519"/>
+            <a:ext cx="1554480" cy="274320"/>
           </a:xfrm>
           <a:prstGeom prst="rect">
             <a:avLst/>
@@ -12775,8 +12775,8 @@
         </p:nvSpPr>
         <p:spPr>
           <a:xfrm>
-            <a:off x="1038225" y="1874519"/>
-            <a:ext cx="5486400" cy="274320"/>
+            <a:off x="2226945" y="1874519"/>
+            <a:ext cx="3108960" cy="274320"/>
           </a:xfrm>
           <a:prstGeom prst="rect">
             <a:avLst/>
@@ -14285,8 +14285,8 @@
         </p:nvSpPr>
         <p:spPr>
           <a:xfrm>
-            <a:off x="1038225" y="1874519"/>
-            <a:ext cx="2606040" cy="274320"/>
+            <a:off x="2226945" y="1874519"/>
+            <a:ext cx="1554480" cy="274320"/>
           </a:xfrm>
           <a:prstGeom prst="rect">
             <a:avLst/>
@@ -14331,8 +14331,8 @@
         </p:nvSpPr>
         <p:spPr>
           <a:xfrm>
-            <a:off x="3918585" y="1874519"/>
-            <a:ext cx="2606040" cy="274320"/>
+            <a:off x="3781425" y="1874519"/>
+            <a:ext cx="1554480" cy="274320"/>
           </a:xfrm>
           <a:prstGeom prst="rect">
             <a:avLst/>
@@ -14377,8 +14377,8 @@
         </p:nvSpPr>
         <p:spPr>
           <a:xfrm>
-            <a:off x="1038225" y="1874519"/>
-            <a:ext cx="5486400" cy="274320"/>
+            <a:off x="2226945" y="1874519"/>
+            <a:ext cx="3108960" cy="274320"/>
           </a:xfrm>
           <a:prstGeom prst="rect">
             <a:avLst/>
@@ -15887,8 +15887,8 @@
         </p:nvSpPr>
         <p:spPr>
           <a:xfrm>
-            <a:off x="1038225" y="1874519"/>
-            <a:ext cx="2606040" cy="274320"/>
+            <a:off x="2226945" y="1874519"/>
+            <a:ext cx="1554480" cy="274320"/>
           </a:xfrm>
           <a:prstGeom prst="rect">
             <a:avLst/>
@@ -15933,8 +15933,8 @@
         </p:nvSpPr>
         <p:spPr>
           <a:xfrm>
-            <a:off x="3918585" y="1874519"/>
-            <a:ext cx="2606040" cy="274320"/>
+            <a:off x="3781425" y="1874519"/>
+            <a:ext cx="1554480" cy="274320"/>
           </a:xfrm>
           <a:prstGeom prst="rect">
             <a:avLst/>
@@ -15979,8 +15979,8 @@
         </p:nvSpPr>
         <p:spPr>
           <a:xfrm>
-            <a:off x="1038225" y="1874519"/>
-            <a:ext cx="5486400" cy="274320"/>
+            <a:off x="2226945" y="1874519"/>
+            <a:ext cx="3108960" cy="274320"/>
           </a:xfrm>
           <a:prstGeom prst="rect">
             <a:avLst/>
@@ -19950,8 +19950,8 @@
         </p:nvSpPr>
         <p:spPr>
           <a:xfrm>
-            <a:off x="1038225" y="1874519"/>
-            <a:ext cx="2606040" cy="274320"/>
+            <a:off x="2226945" y="1874519"/>
+            <a:ext cx="1554480" cy="274320"/>
           </a:xfrm>
           <a:prstGeom prst="rect">
             <a:avLst/>
@@ -19996,8 +19996,8 @@
         </p:nvSpPr>
         <p:spPr>
           <a:xfrm>
-            <a:off x="3918585" y="1874519"/>
-            <a:ext cx="2606040" cy="274320"/>
+            <a:off x="3781425" y="1874519"/>
+            <a:ext cx="1554480" cy="274320"/>
           </a:xfrm>
           <a:prstGeom prst="rect">
             <a:avLst/>
@@ -20042,8 +20042,8 @@
         </p:nvSpPr>
         <p:spPr>
           <a:xfrm>
-            <a:off x="1038225" y="1874519"/>
-            <a:ext cx="5486400" cy="274320"/>
+            <a:off x="2226945" y="1874519"/>
+            <a:ext cx="3108960" cy="274320"/>
           </a:xfrm>
           <a:prstGeom prst="rect">
             <a:avLst/>
@@ -21552,8 +21552,8 @@
         </p:nvSpPr>
         <p:spPr>
           <a:xfrm>
-            <a:off x="1038225" y="1874519"/>
-            <a:ext cx="2606040" cy="274320"/>
+            <a:off x="2226945" y="1874519"/>
+            <a:ext cx="1554480" cy="274320"/>
           </a:xfrm>
           <a:prstGeom prst="rect">
             <a:avLst/>
@@ -21598,8 +21598,8 @@
         </p:nvSpPr>
         <p:spPr>
           <a:xfrm>
-            <a:off x="3918585" y="1874519"/>
-            <a:ext cx="2606040" cy="274320"/>
+            <a:off x="3781425" y="1874519"/>
+            <a:ext cx="1554480" cy="274320"/>
           </a:xfrm>
           <a:prstGeom prst="rect">
             <a:avLst/>
@@ -21644,8 +21644,8 @@
         </p:nvSpPr>
         <p:spPr>
           <a:xfrm>
-            <a:off x="1038225" y="1874519"/>
-            <a:ext cx="5486400" cy="274320"/>
+            <a:off x="2226945" y="1874519"/>
+            <a:ext cx="3108960" cy="274320"/>
           </a:xfrm>
           <a:prstGeom prst="rect">
             <a:avLst/>
@@ -23154,8 +23154,8 @@
         </p:nvSpPr>
         <p:spPr>
           <a:xfrm>
-            <a:off x="1038225" y="1874519"/>
-            <a:ext cx="2606040" cy="274320"/>
+            <a:off x="2226945" y="1874519"/>
+            <a:ext cx="1554480" cy="274320"/>
           </a:xfrm>
           <a:prstGeom prst="rect">
             <a:avLst/>
@@ -23200,8 +23200,8 @@
         </p:nvSpPr>
         <p:spPr>
           <a:xfrm>
-            <a:off x="3918585" y="1874519"/>
-            <a:ext cx="2606040" cy="274320"/>
+            <a:off x="3781425" y="1874519"/>
+            <a:ext cx="1554480" cy="274320"/>
           </a:xfrm>
           <a:prstGeom prst="rect">
             <a:avLst/>
@@ -23246,8 +23246,8 @@
         </p:nvSpPr>
         <p:spPr>
           <a:xfrm>
-            <a:off x="1038225" y="1874519"/>
-            <a:ext cx="5486400" cy="274320"/>
+            <a:off x="2226945" y="1874519"/>
+            <a:ext cx="3108960" cy="274320"/>
           </a:xfrm>
           <a:prstGeom prst="rect">
             <a:avLst/>
@@ -25504,8 +25504,8 @@
         </p:nvSpPr>
         <p:spPr>
           <a:xfrm>
-            <a:off x="1038225" y="1874519"/>
-            <a:ext cx="2606040" cy="274320"/>
+            <a:off x="2226945" y="1874519"/>
+            <a:ext cx="1554480" cy="274320"/>
           </a:xfrm>
           <a:prstGeom prst="rect">
             <a:avLst/>
@@ -25550,8 +25550,8 @@
         </p:nvSpPr>
         <p:spPr>
           <a:xfrm>
-            <a:off x="3918585" y="1874519"/>
-            <a:ext cx="2606040" cy="274320"/>
+            <a:off x="3781425" y="1874519"/>
+            <a:ext cx="1554480" cy="274320"/>
           </a:xfrm>
           <a:prstGeom prst="rect">
             <a:avLst/>
@@ -25596,8 +25596,8 @@
         </p:nvSpPr>
         <p:spPr>
           <a:xfrm>
-            <a:off x="1038225" y="1874519"/>
-            <a:ext cx="5486400" cy="274320"/>
+            <a:off x="2226945" y="1874519"/>
+            <a:ext cx="3108960" cy="274320"/>
           </a:xfrm>
           <a:prstGeom prst="rect">
             <a:avLst/>
@@ -27106,8 +27106,8 @@
         </p:nvSpPr>
         <p:spPr>
           <a:xfrm>
-            <a:off x="1038225" y="1874519"/>
-            <a:ext cx="2606040" cy="274320"/>
+            <a:off x="2226945" y="1874519"/>
+            <a:ext cx="1554480" cy="274320"/>
           </a:xfrm>
           <a:prstGeom prst="rect">
             <a:avLst/>
@@ -27152,8 +27152,8 @@
         </p:nvSpPr>
         <p:spPr>
           <a:xfrm>
-            <a:off x="3918585" y="1874519"/>
-            <a:ext cx="2606040" cy="274320"/>
+            <a:off x="3781425" y="1874519"/>
+            <a:ext cx="1554480" cy="274320"/>
           </a:xfrm>
           <a:prstGeom prst="rect">
             <a:avLst/>
@@ -27198,8 +27198,8 @@
         </p:nvSpPr>
         <p:spPr>
           <a:xfrm>
-            <a:off x="1038225" y="1874519"/>
-            <a:ext cx="5486400" cy="274320"/>
+            <a:off x="2226945" y="1874519"/>
+            <a:ext cx="3108960" cy="274320"/>
           </a:xfrm>
           <a:prstGeom prst="rect">
             <a:avLst/>
@@ -40749,8 +40749,8 @@
         </p:nvSpPr>
         <p:spPr>
           <a:xfrm>
-            <a:off x="1038225" y="1874519"/>
-            <a:ext cx="2606040" cy="274320"/>
+            <a:off x="2226945" y="1874519"/>
+            <a:ext cx="1554480" cy="274320"/>
           </a:xfrm>
           <a:prstGeom prst="rect">
             <a:avLst/>
@@ -40795,8 +40795,8 @@
         </p:nvSpPr>
         <p:spPr>
           <a:xfrm>
-            <a:off x="3918585" y="1874519"/>
-            <a:ext cx="2606040" cy="274320"/>
+            <a:off x="3781425" y="1874519"/>
+            <a:ext cx="1554480" cy="274320"/>
           </a:xfrm>
           <a:prstGeom prst="rect">
             <a:avLst/>
@@ -40841,8 +40841,8 @@
         </p:nvSpPr>
         <p:spPr>
           <a:xfrm>
-            <a:off x="1038225" y="1874519"/>
-            <a:ext cx="5486400" cy="274320"/>
+            <a:off x="2226945" y="1874519"/>
+            <a:ext cx="3108960" cy="274320"/>
           </a:xfrm>
           <a:prstGeom prst="rect">
             <a:avLst/>
@@ -42351,8 +42351,8 @@
         </p:nvSpPr>
         <p:spPr>
           <a:xfrm>
-            <a:off x="1038225" y="1874519"/>
-            <a:ext cx="2606040" cy="274320"/>
+            <a:off x="2226945" y="1874519"/>
+            <a:ext cx="1554480" cy="274320"/>
           </a:xfrm>
           <a:prstGeom prst="rect">
             <a:avLst/>
@@ -42397,8 +42397,8 @@
         </p:nvSpPr>
         <p:spPr>
           <a:xfrm>
-            <a:off x="3918585" y="1874519"/>
-            <a:ext cx="2606040" cy="274320"/>
+            <a:off x="3781425" y="1874519"/>
+            <a:ext cx="1554480" cy="274320"/>
           </a:xfrm>
           <a:prstGeom prst="rect">
             <a:avLst/>
@@ -42443,8 +42443,8 @@
         </p:nvSpPr>
         <p:spPr>
           <a:xfrm>
-            <a:off x="1038225" y="1874519"/>
-            <a:ext cx="5486400" cy="274320"/>
+            <a:off x="2226945" y="1874519"/>
+            <a:ext cx="3108960" cy="274320"/>
           </a:xfrm>
           <a:prstGeom prst="rect">
             <a:avLst/>
@@ -43953,8 +43953,8 @@
         </p:nvSpPr>
         <p:spPr>
           <a:xfrm>
-            <a:off x="1038225" y="1874519"/>
-            <a:ext cx="2606040" cy="274320"/>
+            <a:off x="2226945" y="1874519"/>
+            <a:ext cx="1554480" cy="274320"/>
           </a:xfrm>
           <a:prstGeom prst="rect">
             <a:avLst/>
@@ -43999,8 +43999,8 @@
         </p:nvSpPr>
         <p:spPr>
           <a:xfrm>
-            <a:off x="3918585" y="1874519"/>
-            <a:ext cx="2606040" cy="274320"/>
+            <a:off x="3781425" y="1874519"/>
+            <a:ext cx="1554480" cy="274320"/>
           </a:xfrm>
           <a:prstGeom prst="rect">
             <a:avLst/>
@@ -44045,8 +44045,8 @@
         </p:nvSpPr>
         <p:spPr>
           <a:xfrm>
-            <a:off x="1038225" y="1874519"/>
-            <a:ext cx="5486400" cy="274320"/>
+            <a:off x="2226945" y="1874519"/>
+            <a:ext cx="3108960" cy="274320"/>
           </a:xfrm>
           <a:prstGeom prst="rect">
             <a:avLst/>
@@ -45555,8 +45555,8 @@
         </p:nvSpPr>
         <p:spPr>
           <a:xfrm>
-            <a:off x="1038225" y="1874519"/>
-            <a:ext cx="2606040" cy="274320"/>
+            <a:off x="2226945" y="1874519"/>
+            <a:ext cx="1554480" cy="274320"/>
           </a:xfrm>
           <a:prstGeom prst="rect">
             <a:avLst/>
@@ -45601,8 +45601,8 @@
         </p:nvSpPr>
         <p:spPr>
           <a:xfrm>
-            <a:off x="3918585" y="1874519"/>
-            <a:ext cx="2606040" cy="274320"/>
+            <a:off x="3781425" y="1874519"/>
+            <a:ext cx="1554480" cy="274320"/>
           </a:xfrm>
           <a:prstGeom prst="rect">
             <a:avLst/>
@@ -45647,8 +45647,8 @@
         </p:nvSpPr>
         <p:spPr>
           <a:xfrm>
-            <a:off x="1038225" y="1874519"/>
-            <a:ext cx="5486400" cy="274320"/>
+            <a:off x="2226945" y="1874519"/>
+            <a:ext cx="3108960" cy="274320"/>
           </a:xfrm>
           <a:prstGeom prst="rect">
             <a:avLst/>

</xml_diff>

<commit_message>
Add gap between Before/After half-square photo frames
https://claude.ai/code/session_016Wb6e5A68fyGWAtZg4KdQn
</commit_message>
<xml_diff>
--- a/鼻整形_デザインカタログ.pptx
+++ b/鼻整形_デザインカタログ.pptx
@@ -757,7 +757,7 @@
         </p:nvSpPr>
         <p:spPr>
           <a:xfrm>
-            <a:off x="2226945" y="2240280"/>
+            <a:off x="2066925" y="2240280"/>
             <a:ext cx="1554480" cy="3108960"/>
           </a:xfrm>
           <a:prstGeom prst="roundRect">
@@ -787,7 +787,7 @@
         </p:nvSpPr>
         <p:spPr>
           <a:xfrm>
-            <a:off x="3781425" y="2240280"/>
+            <a:off x="3941445" y="2240280"/>
             <a:ext cx="1554480" cy="3108960"/>
           </a:xfrm>
           <a:prstGeom prst="roundRect">
@@ -5389,7 +5389,7 @@
         </p:nvSpPr>
         <p:spPr>
           <a:xfrm>
-            <a:off x="2226945" y="1874519"/>
+            <a:off x="2066925" y="1874519"/>
             <a:ext cx="1554480" cy="274320"/>
           </a:xfrm>
           <a:prstGeom prst="rect">
@@ -5435,7 +5435,7 @@
         </p:nvSpPr>
         <p:spPr>
           <a:xfrm>
-            <a:off x="3781425" y="1874519"/>
+            <a:off x="3941445" y="1874519"/>
             <a:ext cx="1554480" cy="274320"/>
           </a:xfrm>
           <a:prstGeom prst="rect">
@@ -5481,8 +5481,8 @@
         </p:nvSpPr>
         <p:spPr>
           <a:xfrm>
-            <a:off x="2226945" y="1874519"/>
-            <a:ext cx="3108960" cy="274320"/>
+            <a:off x="2066925" y="1874519"/>
+            <a:ext cx="3429000" cy="274320"/>
           </a:xfrm>
           <a:prstGeom prst="rect">
             <a:avLst/>
@@ -6991,7 +6991,7 @@
         </p:nvSpPr>
         <p:spPr>
           <a:xfrm>
-            <a:off x="2226945" y="1874519"/>
+            <a:off x="2066925" y="1874519"/>
             <a:ext cx="1554480" cy="274320"/>
           </a:xfrm>
           <a:prstGeom prst="rect">
@@ -7037,7 +7037,7 @@
         </p:nvSpPr>
         <p:spPr>
           <a:xfrm>
-            <a:off x="3781425" y="1874519"/>
+            <a:off x="3941445" y="1874519"/>
             <a:ext cx="1554480" cy="274320"/>
           </a:xfrm>
           <a:prstGeom prst="rect">
@@ -7083,8 +7083,8 @@
         </p:nvSpPr>
         <p:spPr>
           <a:xfrm>
-            <a:off x="2226945" y="1874519"/>
-            <a:ext cx="3108960" cy="274320"/>
+            <a:off x="2066925" y="1874519"/>
+            <a:ext cx="3429000" cy="274320"/>
           </a:xfrm>
           <a:prstGeom prst="rect">
             <a:avLst/>
@@ -8593,7 +8593,7 @@
         </p:nvSpPr>
         <p:spPr>
           <a:xfrm>
-            <a:off x="2226945" y="1874519"/>
+            <a:off x="2066925" y="1874519"/>
             <a:ext cx="1554480" cy="274320"/>
           </a:xfrm>
           <a:prstGeom prst="rect">
@@ -8639,7 +8639,7 @@
         </p:nvSpPr>
         <p:spPr>
           <a:xfrm>
-            <a:off x="3781425" y="1874519"/>
+            <a:off x="3941445" y="1874519"/>
             <a:ext cx="1554480" cy="274320"/>
           </a:xfrm>
           <a:prstGeom prst="rect">
@@ -8685,8 +8685,8 @@
         </p:nvSpPr>
         <p:spPr>
           <a:xfrm>
-            <a:off x="2226945" y="1874519"/>
-            <a:ext cx="3108960" cy="274320"/>
+            <a:off x="2066925" y="1874519"/>
+            <a:ext cx="3429000" cy="274320"/>
           </a:xfrm>
           <a:prstGeom prst="rect">
             <a:avLst/>
@@ -10195,7 +10195,7 @@
         </p:nvSpPr>
         <p:spPr>
           <a:xfrm>
-            <a:off x="2226945" y="1874519"/>
+            <a:off x="2066925" y="1874519"/>
             <a:ext cx="1554480" cy="274320"/>
           </a:xfrm>
           <a:prstGeom prst="rect">
@@ -10241,7 +10241,7 @@
         </p:nvSpPr>
         <p:spPr>
           <a:xfrm>
-            <a:off x="3781425" y="1874519"/>
+            <a:off x="3941445" y="1874519"/>
             <a:ext cx="1554480" cy="274320"/>
           </a:xfrm>
           <a:prstGeom prst="rect">
@@ -10287,8 +10287,8 @@
         </p:nvSpPr>
         <p:spPr>
           <a:xfrm>
-            <a:off x="2226945" y="1874519"/>
-            <a:ext cx="3108960" cy="274320"/>
+            <a:off x="2066925" y="1874519"/>
+            <a:ext cx="3429000" cy="274320"/>
           </a:xfrm>
           <a:prstGeom prst="rect">
             <a:avLst/>
@@ -12683,7 +12683,7 @@
         </p:nvSpPr>
         <p:spPr>
           <a:xfrm>
-            <a:off x="2226945" y="1874519"/>
+            <a:off x="2066925" y="1874519"/>
             <a:ext cx="1554480" cy="274320"/>
           </a:xfrm>
           <a:prstGeom prst="rect">
@@ -12729,7 +12729,7 @@
         </p:nvSpPr>
         <p:spPr>
           <a:xfrm>
-            <a:off x="3781425" y="1874519"/>
+            <a:off x="3941445" y="1874519"/>
             <a:ext cx="1554480" cy="274320"/>
           </a:xfrm>
           <a:prstGeom prst="rect">
@@ -12775,8 +12775,8 @@
         </p:nvSpPr>
         <p:spPr>
           <a:xfrm>
-            <a:off x="2226945" y="1874519"/>
-            <a:ext cx="3108960" cy="274320"/>
+            <a:off x="2066925" y="1874519"/>
+            <a:ext cx="3429000" cy="274320"/>
           </a:xfrm>
           <a:prstGeom prst="rect">
             <a:avLst/>
@@ -14285,7 +14285,7 @@
         </p:nvSpPr>
         <p:spPr>
           <a:xfrm>
-            <a:off x="2226945" y="1874519"/>
+            <a:off x="2066925" y="1874519"/>
             <a:ext cx="1554480" cy="274320"/>
           </a:xfrm>
           <a:prstGeom prst="rect">
@@ -14331,7 +14331,7 @@
         </p:nvSpPr>
         <p:spPr>
           <a:xfrm>
-            <a:off x="3781425" y="1874519"/>
+            <a:off x="3941445" y="1874519"/>
             <a:ext cx="1554480" cy="274320"/>
           </a:xfrm>
           <a:prstGeom prst="rect">
@@ -14377,8 +14377,8 @@
         </p:nvSpPr>
         <p:spPr>
           <a:xfrm>
-            <a:off x="2226945" y="1874519"/>
-            <a:ext cx="3108960" cy="274320"/>
+            <a:off x="2066925" y="1874519"/>
+            <a:ext cx="3429000" cy="274320"/>
           </a:xfrm>
           <a:prstGeom prst="rect">
             <a:avLst/>
@@ -15887,7 +15887,7 @@
         </p:nvSpPr>
         <p:spPr>
           <a:xfrm>
-            <a:off x="2226945" y="1874519"/>
+            <a:off x="2066925" y="1874519"/>
             <a:ext cx="1554480" cy="274320"/>
           </a:xfrm>
           <a:prstGeom prst="rect">
@@ -15933,7 +15933,7 @@
         </p:nvSpPr>
         <p:spPr>
           <a:xfrm>
-            <a:off x="3781425" y="1874519"/>
+            <a:off x="3941445" y="1874519"/>
             <a:ext cx="1554480" cy="274320"/>
           </a:xfrm>
           <a:prstGeom prst="rect">
@@ -15979,8 +15979,8 @@
         </p:nvSpPr>
         <p:spPr>
           <a:xfrm>
-            <a:off x="2226945" y="1874519"/>
-            <a:ext cx="3108960" cy="274320"/>
+            <a:off x="2066925" y="1874519"/>
+            <a:ext cx="3429000" cy="274320"/>
           </a:xfrm>
           <a:prstGeom prst="rect">
             <a:avLst/>
@@ -19950,7 +19950,7 @@
         </p:nvSpPr>
         <p:spPr>
           <a:xfrm>
-            <a:off x="2226945" y="1874519"/>
+            <a:off x="2066925" y="1874519"/>
             <a:ext cx="1554480" cy="274320"/>
           </a:xfrm>
           <a:prstGeom prst="rect">
@@ -19996,7 +19996,7 @@
         </p:nvSpPr>
         <p:spPr>
           <a:xfrm>
-            <a:off x="3781425" y="1874519"/>
+            <a:off x="3941445" y="1874519"/>
             <a:ext cx="1554480" cy="274320"/>
           </a:xfrm>
           <a:prstGeom prst="rect">
@@ -20042,8 +20042,8 @@
         </p:nvSpPr>
         <p:spPr>
           <a:xfrm>
-            <a:off x="2226945" y="1874519"/>
-            <a:ext cx="3108960" cy="274320"/>
+            <a:off x="2066925" y="1874519"/>
+            <a:ext cx="3429000" cy="274320"/>
           </a:xfrm>
           <a:prstGeom prst="rect">
             <a:avLst/>
@@ -21552,7 +21552,7 @@
         </p:nvSpPr>
         <p:spPr>
           <a:xfrm>
-            <a:off x="2226945" y="1874519"/>
+            <a:off x="2066925" y="1874519"/>
             <a:ext cx="1554480" cy="274320"/>
           </a:xfrm>
           <a:prstGeom prst="rect">
@@ -21598,7 +21598,7 @@
         </p:nvSpPr>
         <p:spPr>
           <a:xfrm>
-            <a:off x="3781425" y="1874519"/>
+            <a:off x="3941445" y="1874519"/>
             <a:ext cx="1554480" cy="274320"/>
           </a:xfrm>
           <a:prstGeom prst="rect">
@@ -21644,8 +21644,8 @@
         </p:nvSpPr>
         <p:spPr>
           <a:xfrm>
-            <a:off x="2226945" y="1874519"/>
-            <a:ext cx="3108960" cy="274320"/>
+            <a:off x="2066925" y="1874519"/>
+            <a:ext cx="3429000" cy="274320"/>
           </a:xfrm>
           <a:prstGeom prst="rect">
             <a:avLst/>
@@ -23154,7 +23154,7 @@
         </p:nvSpPr>
         <p:spPr>
           <a:xfrm>
-            <a:off x="2226945" y="1874519"/>
+            <a:off x="2066925" y="1874519"/>
             <a:ext cx="1554480" cy="274320"/>
           </a:xfrm>
           <a:prstGeom prst="rect">
@@ -23200,7 +23200,7 @@
         </p:nvSpPr>
         <p:spPr>
           <a:xfrm>
-            <a:off x="3781425" y="1874519"/>
+            <a:off x="3941445" y="1874519"/>
             <a:ext cx="1554480" cy="274320"/>
           </a:xfrm>
           <a:prstGeom prst="rect">
@@ -23246,8 +23246,8 @@
         </p:nvSpPr>
         <p:spPr>
           <a:xfrm>
-            <a:off x="2226945" y="1874519"/>
-            <a:ext cx="3108960" cy="274320"/>
+            <a:off x="2066925" y="1874519"/>
+            <a:ext cx="3429000" cy="274320"/>
           </a:xfrm>
           <a:prstGeom prst="rect">
             <a:avLst/>
@@ -25504,7 +25504,7 @@
         </p:nvSpPr>
         <p:spPr>
           <a:xfrm>
-            <a:off x="2226945" y="1874519"/>
+            <a:off x="2066925" y="1874519"/>
             <a:ext cx="1554480" cy="274320"/>
           </a:xfrm>
           <a:prstGeom prst="rect">
@@ -25550,7 +25550,7 @@
         </p:nvSpPr>
         <p:spPr>
           <a:xfrm>
-            <a:off x="3781425" y="1874519"/>
+            <a:off x="3941445" y="1874519"/>
             <a:ext cx="1554480" cy="274320"/>
           </a:xfrm>
           <a:prstGeom prst="rect">
@@ -25596,8 +25596,8 @@
         </p:nvSpPr>
         <p:spPr>
           <a:xfrm>
-            <a:off x="2226945" y="1874519"/>
-            <a:ext cx="3108960" cy="274320"/>
+            <a:off x="2066925" y="1874519"/>
+            <a:ext cx="3429000" cy="274320"/>
           </a:xfrm>
           <a:prstGeom prst="rect">
             <a:avLst/>
@@ -27106,7 +27106,7 @@
         </p:nvSpPr>
         <p:spPr>
           <a:xfrm>
-            <a:off x="2226945" y="1874519"/>
+            <a:off x="2066925" y="1874519"/>
             <a:ext cx="1554480" cy="274320"/>
           </a:xfrm>
           <a:prstGeom prst="rect">
@@ -27152,7 +27152,7 @@
         </p:nvSpPr>
         <p:spPr>
           <a:xfrm>
-            <a:off x="3781425" y="1874519"/>
+            <a:off x="3941445" y="1874519"/>
             <a:ext cx="1554480" cy="274320"/>
           </a:xfrm>
           <a:prstGeom prst="rect">
@@ -27198,8 +27198,8 @@
         </p:nvSpPr>
         <p:spPr>
           <a:xfrm>
-            <a:off x="2226945" y="1874519"/>
-            <a:ext cx="3108960" cy="274320"/>
+            <a:off x="2066925" y="1874519"/>
+            <a:ext cx="3429000" cy="274320"/>
           </a:xfrm>
           <a:prstGeom prst="rect">
             <a:avLst/>
@@ -40749,7 +40749,7 @@
         </p:nvSpPr>
         <p:spPr>
           <a:xfrm>
-            <a:off x="2226945" y="1874519"/>
+            <a:off x="2066925" y="1874519"/>
             <a:ext cx="1554480" cy="274320"/>
           </a:xfrm>
           <a:prstGeom prst="rect">
@@ -40795,7 +40795,7 @@
         </p:nvSpPr>
         <p:spPr>
           <a:xfrm>
-            <a:off x="3781425" y="1874519"/>
+            <a:off x="3941445" y="1874519"/>
             <a:ext cx="1554480" cy="274320"/>
           </a:xfrm>
           <a:prstGeom prst="rect">
@@ -40841,8 +40841,8 @@
         </p:nvSpPr>
         <p:spPr>
           <a:xfrm>
-            <a:off x="2226945" y="1874519"/>
-            <a:ext cx="3108960" cy="274320"/>
+            <a:off x="2066925" y="1874519"/>
+            <a:ext cx="3429000" cy="274320"/>
           </a:xfrm>
           <a:prstGeom prst="rect">
             <a:avLst/>
@@ -42351,7 +42351,7 @@
         </p:nvSpPr>
         <p:spPr>
           <a:xfrm>
-            <a:off x="2226945" y="1874519"/>
+            <a:off x="2066925" y="1874519"/>
             <a:ext cx="1554480" cy="274320"/>
           </a:xfrm>
           <a:prstGeom prst="rect">
@@ -42397,7 +42397,7 @@
         </p:nvSpPr>
         <p:spPr>
           <a:xfrm>
-            <a:off x="3781425" y="1874519"/>
+            <a:off x="3941445" y="1874519"/>
             <a:ext cx="1554480" cy="274320"/>
           </a:xfrm>
           <a:prstGeom prst="rect">
@@ -42443,8 +42443,8 @@
         </p:nvSpPr>
         <p:spPr>
           <a:xfrm>
-            <a:off x="2226945" y="1874519"/>
-            <a:ext cx="3108960" cy="274320"/>
+            <a:off x="2066925" y="1874519"/>
+            <a:ext cx="3429000" cy="274320"/>
           </a:xfrm>
           <a:prstGeom prst="rect">
             <a:avLst/>
@@ -43953,7 +43953,7 @@
         </p:nvSpPr>
         <p:spPr>
           <a:xfrm>
-            <a:off x="2226945" y="1874519"/>
+            <a:off x="2066925" y="1874519"/>
             <a:ext cx="1554480" cy="274320"/>
           </a:xfrm>
           <a:prstGeom prst="rect">
@@ -43999,7 +43999,7 @@
         </p:nvSpPr>
         <p:spPr>
           <a:xfrm>
-            <a:off x="3781425" y="1874519"/>
+            <a:off x="3941445" y="1874519"/>
             <a:ext cx="1554480" cy="274320"/>
           </a:xfrm>
           <a:prstGeom prst="rect">
@@ -44045,8 +44045,8 @@
         </p:nvSpPr>
         <p:spPr>
           <a:xfrm>
-            <a:off x="2226945" y="1874519"/>
-            <a:ext cx="3108960" cy="274320"/>
+            <a:off x="2066925" y="1874519"/>
+            <a:ext cx="3429000" cy="274320"/>
           </a:xfrm>
           <a:prstGeom prst="rect">
             <a:avLst/>
@@ -45555,7 +45555,7 @@
         </p:nvSpPr>
         <p:spPr>
           <a:xfrm>
-            <a:off x="2226945" y="1874519"/>
+            <a:off x="2066925" y="1874519"/>
             <a:ext cx="1554480" cy="274320"/>
           </a:xfrm>
           <a:prstGeom prst="rect">
@@ -45601,7 +45601,7 @@
         </p:nvSpPr>
         <p:spPr>
           <a:xfrm>
-            <a:off x="3781425" y="1874519"/>
+            <a:off x="3941445" y="1874519"/>
             <a:ext cx="1554480" cy="274320"/>
           </a:xfrm>
           <a:prstGeom prst="rect">
@@ -45647,8 +45647,8 @@
         </p:nvSpPr>
         <p:spPr>
           <a:xfrm>
-            <a:off x="2226945" y="1874519"/>
-            <a:ext cx="3108960" cy="274320"/>
+            <a:off x="2066925" y="1874519"/>
+            <a:ext cx="3429000" cy="274320"/>
           </a:xfrm>
           <a:prstGeom prst="rect">
             <a:avLst/>

</xml_diff>